<commit_message>
add automatic city catalog
</commit_message>
<xml_diff>
--- a/docs/poster/scientific/umbra-poster-editable.pptx
+++ b/docs/poster/scientific/umbra-poster-editable.pptx
@@ -1521,7 +1521,7 @@
       </p:sp>
       <p:pic>
         <p:nvPicPr>
-          <p:cNvPr id="18" name="Image 0" descr="/home/kawase/Documents/GitHub/umbra/docs/poster/scientific/building-3d.png">    </p:cNvPr>
+          <p:cNvPr id="18" name="Image 0" descr="/home/perjoc/github/umbra/docs/poster/scientific/building-3d.png">    </p:cNvPr>
           <p:cNvPicPr>
             <a:picLocks noChangeAspect="1"/>
           </p:cNvPicPr>
@@ -2082,7 +2082,7 @@
                 <a:ea typeface="Noto Sans" pitchFamily="34" charset="-122"/>
                 <a:cs typeface="Noto Sans" pitchFamily="34" charset="-120"/>
               </a:rPr>
-              <a:t>Instantaneu OSM: 51.428 clădiri; GBA asociat la 40.658 (79,1%).</a:t>
+              <a:t>Instantaneu OSM Constanța: 51.428 clădiri; GBA asociat la 40.658 (79,1%).</a:t>
             </a:r>
             <a:endParaRPr lang="en-US" sz="1200" dirty="0"/>
           </a:p>
@@ -10411,7 +10411,7 @@
                 <a:ea typeface="Noto Sans" pitchFamily="34" charset="-122"/>
                 <a:cs typeface="Noto Sans" pitchFamily="34" charset="-120"/>
               </a:rPr>
-              <a:t>Aplicație testată pe teren în Constanța. Umbra compară traseele și integrează înălțimile confirmate de utilizatori.</a:t>
+              <a:t>Testată pe teren în Constanța. Trasee umbrite în București și în toate reședințele de județ; înălțimi confirmate de utilizatori.</a:t>
             </a:r>
             <a:endParaRPr lang="en-US" sz="1200" dirty="0"/>
           </a:p>

</xml_diff>